<commit_message>
Add four open-curriculum learning tracks and an Open Resource Library
- tracks.json: Intro, Practitioner ML, AI Engineer and Academic tracks
  (16 modules, 48 original lessons with quizzes, activities and 1-3 open
  resources each, labelled with upstream license and fork/link-only status)
- library.json: 41 curated open curricula, free books, university classes
  and LLM build-from-scratch resources with hosting rules
- New pages: #/tracks, #/tracks/:id (syllabus, mastery, resume), #/library
  (filters by type/track/hosting, search, deep-link anchors); track
  certificates via #/certificate?track=:id
- Track-aware breadcrumbs, lesson resources block, global search over
  tracks and library, home stats and tracks section, nav/footer links
- CSS for track thumbs, syllabus, resource rows, library cards and badges;
  fix narrow-viewport overflow in the lesson layout
- Tests for track/library integrity and data routes; README open-content
  policy; pitch deck updated
</commit_message>
<xml_diff>
--- a/pitch/SI-Academy-Pitch-Deck.pptx
+++ b/pitch/SI-Academy-Pitch-Deck.pptx
@@ -1041,7 +1041,7 @@
           <a:p>
             <a:r>
               <a:rPr lang="en-US" dirty="0"/>
-              <a:t>Demo the lesson page: toggle to Chinese, press Listen. Then show the policy generator.</a:t>
+              <a:t>Demo a K–12 lesson: press Listen, take the quiz, watch mastery update. Then open the AI Engineer track and the Open Resource Library, and finish with the policy generator.</a:t>
             </a:r>
             <a:endParaRPr lang="en-US" dirty="0"/>
           </a:p>
@@ -2128,7 +2128,7 @@
                 <a:ea typeface="IBM Plex Sans" pitchFamily="34" charset="-122"/>
                 <a:cs typeface="IBM Plex Sans" pitchFamily="34" charset="-120"/>
               </a:rPr>
-              <a:t>Open-source K–12 AI literacy platform — Khan-style mastery, Plan B-style clarity</a:t>
+              <a:t>Open-source AI literacy platform — K–12 curriculum plus four open learning tracks, Khan-style mastery, Plan B-style clarity</a:t>
             </a:r>
             <a:endParaRPr lang="en-US" sz="1700" dirty="0"/>
           </a:p>
@@ -2230,7 +2230,7 @@
                 <a:ea typeface="IBM Plex Mono" pitchFamily="34" charset="-122"/>
                 <a:cs typeface="IBM Plex Mono" pitchFamily="34" charset="-120"/>
               </a:rPr>
-              <a:t>Super Intelligence Academy — K–12 AI literacy with ElevenLabs voice-over</a:t>
+              <a:t>Super Intelligence Academy — K–12 AI literacy and open learning tracks with ElevenLabs voice-over</a:t>
             </a:r>
             <a:endParaRPr lang="en-US" sz="1100" dirty="0"/>
           </a:p>
@@ -2562,7 +2562,7 @@
                 <a:ea typeface="IBM Plex Sans" pitchFamily="34" charset="-122"/>
                 <a:cs typeface="IBM Plex Sans" pitchFamily="34" charset="-120"/>
               </a:rPr>
-              <a:t>✅ Working platform: 8 modules, 12 lessons, quizzes, certificates, Teacher Hub, policy explorer — live on GitHub Pages</a:t>
+              <a:t>✅ Working platform: 8 K–12 modules + 4 learning tracks (16 modules, 48 lessons, 100+ open-resource links), quizzes, certificates, Teacher Hub, Open Resource Library, policy explorer — live on GitHub Pages</a:t>
             </a:r>
             <a:endParaRPr lang="en-US" sz="1450" dirty="0"/>
           </a:p>
@@ -2625,7 +2625,7 @@
                 <a:ea typeface="IBM Plex Sans" pitchFamily="34" charset="-122"/>
                 <a:cs typeface="IBM Plex Sans" pitchFamily="34" charset="-120"/>
               </a:rPr>
-              <a:t>2027: LMS integrations, analytics, 20+ lessons per grade band, educator micro-credential</a:t>
+              <a:t>2027: LMS integrations, analytics, 20+ lessons per grade band, mirrored notebooks for fork-licensed curricula, educator micro-credential</a:t>
             </a:r>
             <a:endParaRPr lang="en-US" sz="1450" dirty="0"/>
           </a:p>
@@ -3309,7 +3309,7 @@
                 <a:ea typeface="IBM Plex Sans" pitchFamily="34" charset="-122"/>
                 <a:cs typeface="IBM Plex Sans" pitchFamily="34" charset="-120"/>
               </a:rPr>
-              <a:t>Thank you · 谢谢</a:t>
+              <a:t>Thank you</a:t>
             </a:r>
             <a:endParaRPr lang="en-US" sz="3200" dirty="0"/>
           </a:p>
@@ -4558,7 +4558,7 @@
                 <a:ea typeface="IBM Plex Sans" pitchFamily="34" charset="-122"/>
                 <a:cs typeface="IBM Plex Sans" pitchFamily="34" charset="-120"/>
               </a:rPr>
-              <a:t>Teacher Hub: traffic-light AI-use policy generator + disclosure templates</a:t>
+              <a:t>Beyond K–12: four learning tracks (Intro · Practitioner ML · AI Engineer · Academic) — 16 modules, 48 original lessons built on Microsoft, Hugging Face, fast.ai, d2l.ai, Karpathy and Stanford/MIT open courses</a:t>
             </a:r>
             <a:endParaRPr lang="en-US" sz="1450" dirty="0"/>
           </a:p>
@@ -4579,7 +4579,28 @@
                 <a:ea typeface="IBM Plex Sans" pitchFamily="34" charset="-122"/>
                 <a:cs typeface="IBM Plex Sans" pitchFamily="34" charset="-120"/>
               </a:rPr>
-              <a:t>Parent portal &amp; Provincial Policy Explorer</a:t>
+              <a:t>Open Resource Library: 41 curated curricula, books and classes with license and fork/link-only status — no rehosted copyrighted PDFs</a:t>
+            </a:r>
+            <a:endParaRPr lang="en-US" sz="1450" dirty="0"/>
+          </a:p>
+          <a:p>
+            <a:pPr marL="342900" indent="-342900">
+              <a:spcAft>
+                <a:spcPts val="700"/>
+              </a:spcAft>
+              <a:buSzPct val="100000"/>
+              <a:buChar char="■"/>
+            </a:pPr>
+            <a:r>
+              <a:rPr lang="en-US" sz="1450" dirty="0">
+                <a:solidFill>
+                  <a:srgbClr val="21242C"/>
+                </a:solidFill>
+                <a:latin typeface="IBM Plex Sans" pitchFamily="34" charset="0"/>
+                <a:ea typeface="IBM Plex Sans" pitchFamily="34" charset="-122"/>
+                <a:cs typeface="IBM Plex Sans" pitchFamily="34" charset="-120"/>
+              </a:rPr>
+              <a:t>Teacher Hub: traffic-light AI-use policy generator + disclosure templates · Parent portal · Provincial Policy Explorer</a:t>
             </a:r>
             <a:endParaRPr lang="en-US" sz="1450" dirty="0"/>
           </a:p>
@@ -6596,7 +6617,7 @@
                 <a:ea typeface="IBM Plex Sans" pitchFamily="34" charset="-122"/>
                 <a:cs typeface="IBM Plex Sans" pitchFamily="34" charset="-120"/>
               </a:rPr>
-              <a:t>Us: Canada-specific · curriculum-mapped · voice-over · policy generator · open-source</a:t>
+              <a:t>Us: Canada-specific · curriculum-mapped · voice-over · policy generator · open-source · a free on-ramp from K–12 to practitioner and research tracks</a:t>
             </a:r>
             <a:endParaRPr lang="en-US" sz="1450" dirty="0"/>
           </a:p>

</xml_diff>